<commit_message>
Reconcile all weekly deck assignments
</commit_message>
<xml_diff>
--- a/STARLAB_Slide_Decks_All/01_Authentic_Research_Course_Launch_2.0.pptx
+++ b/STARLAB_Slide_Decks_All/01_Authentic_Research_Course_Launch_2.0.pptx
@@ -2,37 +2,37 @@
 <file path=ppt/presentation.xml><?xml version="1.0" encoding="utf-8"?>
 <p:presentation xmlns:p="http://schemas.openxmlformats.org/presentationml/2006/main" embedTrueTypeFonts="1" saveSubsetFonts="0">
   <p:sldMasterIdLst>
-    <p:sldMasterId xmlns:r="http://schemas.openxmlformats.org/officeDocument/2006/relationships" id="2147483648" r:id="R54730afca3ba45fd"/>
+    <p:sldMasterId xmlns:r="http://schemas.openxmlformats.org/officeDocument/2006/relationships" id="2147483648" r:id="R13d87c35e68f4a63"/>
   </p:sldMasterIdLst>
   <p:notesMasterIdLst>
-    <p:notesMasterId xmlns:r="http://schemas.openxmlformats.org/officeDocument/2006/relationships" r:id="Rf092ef74e71744df"/>
+    <p:notesMasterId xmlns:r="http://schemas.openxmlformats.org/officeDocument/2006/relationships" r:id="R096b58a7ebfa42e3"/>
   </p:notesMasterIdLst>
   <p:sldIdLst>
-    <p:sldId xmlns:r="http://schemas.openxmlformats.org/officeDocument/2006/relationships" id="256" r:id="Rab9a0bd7e5604bff"/>
-    <p:sldId xmlns:r="http://schemas.openxmlformats.org/officeDocument/2006/relationships" id="257" r:id="R5842c8fc804641ff"/>
-    <p:sldId xmlns:r="http://schemas.openxmlformats.org/officeDocument/2006/relationships" id="258" r:id="R6c6d669f7668486d"/>
-    <p:sldId xmlns:r="http://schemas.openxmlformats.org/officeDocument/2006/relationships" id="259" r:id="Rc89a12652cba4c6e"/>
-    <p:sldId xmlns:r="http://schemas.openxmlformats.org/officeDocument/2006/relationships" id="260" r:id="R21ef88f8101749bf"/>
-    <p:sldId xmlns:r="http://schemas.openxmlformats.org/officeDocument/2006/relationships" id="261" r:id="Re88ac5868ba047fd"/>
-    <p:sldId xmlns:r="http://schemas.openxmlformats.org/officeDocument/2006/relationships" id="262" r:id="R68db974db7ae426c"/>
-    <p:sldId xmlns:r="http://schemas.openxmlformats.org/officeDocument/2006/relationships" id="263" r:id="Rc33a6edf03f5429a"/>
-    <p:sldId xmlns:r="http://schemas.openxmlformats.org/officeDocument/2006/relationships" id="264" r:id="Rca6fe907d4374b08"/>
-    <p:sldId xmlns:r="http://schemas.openxmlformats.org/officeDocument/2006/relationships" id="265" r:id="R0387ac118b394f51"/>
-    <p:sldId xmlns:r="http://schemas.openxmlformats.org/officeDocument/2006/relationships" id="266" r:id="Re02332909dac4046"/>
-    <p:sldId xmlns:r="http://schemas.openxmlformats.org/officeDocument/2006/relationships" id="267" r:id="Ra9f574d0ba8048fa"/>
-    <p:sldId xmlns:r="http://schemas.openxmlformats.org/officeDocument/2006/relationships" id="268" r:id="R5f9becf0574d44b6"/>
-    <p:sldId xmlns:r="http://schemas.openxmlformats.org/officeDocument/2006/relationships" id="269" r:id="R36b947b2e0414b5a"/>
-    <p:sldId xmlns:r="http://schemas.openxmlformats.org/officeDocument/2006/relationships" id="270" r:id="R8ac875f1f1e04aea"/>
-    <p:sldId xmlns:r="http://schemas.openxmlformats.org/officeDocument/2006/relationships" id="271" r:id="Rb7e73ddba9804d19"/>
-    <p:sldId xmlns:r="http://schemas.openxmlformats.org/officeDocument/2006/relationships" id="272" r:id="R387f0808bfc64bf6"/>
+    <p:sldId xmlns:r="http://schemas.openxmlformats.org/officeDocument/2006/relationships" id="256" r:id="R4c933da7dfba4522"/>
+    <p:sldId xmlns:r="http://schemas.openxmlformats.org/officeDocument/2006/relationships" id="257" r:id="Re56453b1c028458e"/>
+    <p:sldId xmlns:r="http://schemas.openxmlformats.org/officeDocument/2006/relationships" id="258" r:id="R00dc77bcc42a42b4"/>
+    <p:sldId xmlns:r="http://schemas.openxmlformats.org/officeDocument/2006/relationships" id="259" r:id="R6b408aa30332433b"/>
+    <p:sldId xmlns:r="http://schemas.openxmlformats.org/officeDocument/2006/relationships" id="260" r:id="Re70936bdc8574cd4"/>
+    <p:sldId xmlns:r="http://schemas.openxmlformats.org/officeDocument/2006/relationships" id="261" r:id="R4947638a75114e02"/>
+    <p:sldId xmlns:r="http://schemas.openxmlformats.org/officeDocument/2006/relationships" id="262" r:id="R470c5b93026e496e"/>
+    <p:sldId xmlns:r="http://schemas.openxmlformats.org/officeDocument/2006/relationships" id="263" r:id="Rca2c4d53c1a548d4"/>
+    <p:sldId xmlns:r="http://schemas.openxmlformats.org/officeDocument/2006/relationships" id="264" r:id="R80f3b773917147f7"/>
+    <p:sldId xmlns:r="http://schemas.openxmlformats.org/officeDocument/2006/relationships" id="265" r:id="R72a9fbdef93443a6"/>
+    <p:sldId xmlns:r="http://schemas.openxmlformats.org/officeDocument/2006/relationships" id="266" r:id="Rca7e2d0d8323441b"/>
+    <p:sldId xmlns:r="http://schemas.openxmlformats.org/officeDocument/2006/relationships" id="267" r:id="R9f9bf39146dc4dfc"/>
+    <p:sldId xmlns:r="http://schemas.openxmlformats.org/officeDocument/2006/relationships" id="268" r:id="R6247760b0b7c457e"/>
+    <p:sldId xmlns:r="http://schemas.openxmlformats.org/officeDocument/2006/relationships" id="269" r:id="R93684baa530d472a"/>
+    <p:sldId xmlns:r="http://schemas.openxmlformats.org/officeDocument/2006/relationships" id="270" r:id="Rf0fa9cbbdce34b61"/>
+    <p:sldId xmlns:r="http://schemas.openxmlformats.org/officeDocument/2006/relationships" id="271" r:id="R014843ccf8024db3"/>
+    <p:sldId xmlns:r="http://schemas.openxmlformats.org/officeDocument/2006/relationships" id="272" r:id="R74bc1c8bcaef4add"/>
   </p:sldIdLst>
   <p:sldSz cx="12192000" cy="6858000"/>
   <p:notesSz cx="6858000" cy="9144000"/>
   <p:embeddedFontLst>
     <p:embeddedFont>
       <p:font typeface="Play"/>
-      <p:regular xmlns:r="http://schemas.openxmlformats.org/officeDocument/2006/relationships" r:id="Rf29e73e84c8c4f1c"/>
-      <p:bold xmlns:r="http://schemas.openxmlformats.org/officeDocument/2006/relationships" r:id="R74656550488f44e6"/>
+      <p:regular xmlns:r="http://schemas.openxmlformats.org/officeDocument/2006/relationships" r:id="R89be70f94fe9437e"/>
+      <p:bold xmlns:r="http://schemas.openxmlformats.org/officeDocument/2006/relationships" r:id="Rb3826b5d4fd246ba"/>
     </p:embeddedFont>
   </p:embeddedFontLst>
   <p:defaultTextStyle>
@@ -634,7 +634,7 @@
               <a:buNone/>
             </a:pPr>
             <a:r>
-              <a:t>PAIRED DECK</a:t>
+              <a:t>PAIRED PRIMARY DECK</a:t>
             </a:r>
           </a:p>
           <a:p xmlns:a="http://schemas.openxmlformats.org/drawingml/2006/main">
@@ -690,7 +690,7 @@
               <a:buNone/>
             </a:pPr>
             <a:r>
-              <a:t>Shared weekly packet for Decks 1 and 3:</a:t>
+              <a:t>- Unit 1 Student Handouts 1-4</a:t>
             </a:r>
           </a:p>
           <a:p xmlns:a="http://schemas.openxmlformats.org/drawingml/2006/main">
@@ -704,7 +704,7 @@
               <a:buNone/>
             </a:pPr>
             <a:r>
-              <a:t>- Unit 1 Student Handouts 1-4</a:t>
+              <a:t>- Unit 1 Appendices A-C</a:t>
             </a:r>
           </a:p>
           <a:p xmlns:a="http://schemas.openxmlformats.org/drawingml/2006/main">
@@ -718,7 +718,7 @@
               <a:buNone/>
             </a:pPr>
             <a:r>
-              <a:t>- Unit 1 Appendices A-C</a:t>
+              <a:t/>
             </a:r>
           </a:p>
           <a:p xmlns:a="http://schemas.openxmlformats.org/drawingml/2006/main">
@@ -732,7 +732,7 @@
               <a:buNone/>
             </a:pPr>
             <a:r>
-              <a:t/>
+              <a:t>RESOURCE ALIGNMENT</a:t>
             </a:r>
           </a:p>
           <a:p xmlns:a="http://schemas.openxmlformats.org/drawingml/2006/main">
@@ -746,77 +746,7 @@
               <a:buNone/>
             </a:pPr>
             <a:r>
-              <a:t>OPTIONAL / TEACHER REFERENCE</a:t>
-            </a:r>
-          </a:p>
-          <a:p xmlns:a="http://schemas.openxmlformats.org/drawingml/2006/main">
-            <a:pPr marL="0" indent="0" algn="l">
-              <a:spcBef>
-                <a:spcPts val="0"/>
-              </a:spcBef>
-              <a:spcAft>
-                <a:spcPts val="0"/>
-              </a:spcAft>
-              <a:buNone/>
-            </a:pPr>
-            <a:r>
-              <a:t>- STARLAB syllabus or course overview</a:t>
-            </a:r>
-          </a:p>
-          <a:p xmlns:a="http://schemas.openxmlformats.org/drawingml/2006/main">
-            <a:pPr marL="0" indent="0" algn="l">
-              <a:spcBef>
-                <a:spcPts val="0"/>
-              </a:spcBef>
-              <a:spcAft>
-                <a:spcPts val="0"/>
-              </a:spcAft>
-              <a:buNone/>
-            </a:pPr>
-            <a:r>
-              <a:t>- Student onboarding packet, if used locally</a:t>
-            </a:r>
-          </a:p>
-          <a:p xmlns:a="http://schemas.openxmlformats.org/drawingml/2006/main">
-            <a:pPr marL="0" indent="0" algn="l">
-              <a:spcBef>
-                <a:spcPts val="0"/>
-              </a:spcBef>
-              <a:spcAft>
-                <a:spcPts val="0"/>
-              </a:spcAft>
-              <a:buNone/>
-            </a:pPr>
-            <a:r>
-              <a:t/>
-            </a:r>
-          </a:p>
-          <a:p xmlns:a="http://schemas.openxmlformats.org/drawingml/2006/main">
-            <a:pPr marL="0" indent="0" algn="l">
-              <a:spcBef>
-                <a:spcPts val="0"/>
-              </a:spcBef>
-              <a:spcAft>
-                <a:spcPts val="0"/>
-              </a:spcAft>
-              <a:buNone/>
-            </a:pPr>
-            <a:r>
-              <a:t>RESOURCE ALIGNMENT</a:t>
-            </a:r>
-          </a:p>
-          <a:p xmlns:a="http://schemas.openxmlformats.org/drawingml/2006/main">
-            <a:pPr marL="0" indent="0" algn="l">
-              <a:spcBef>
-                <a:spcPts val="0"/>
-              </a:spcBef>
-              <a:spcAft>
-                <a:spcPts val="0"/>
-              </a:spcAft>
-              <a:buNone/>
-            </a:pPr>
-            <a:r>
-              <a:t>The implementation calendar is the source of truth for week, deck, and print mappings. Preview all Week 1 materials before launching the course.</a:t>
+              <a:t>The implementation calendar is the source of truth for week, deck, and print mappings. This deck has no separately scheduled revisit week.</a:t>
             </a:r>
           </a:p>
         </p:txBody>
@@ -2358,7 +2288,7 @@
   </p:cSld>
   <p:clrMap bg1="lt1" tx1="dk1" bg2="dk2" tx2="lt2" accent1="accent1" accent2="accent2" accent3="accent3" accent4="accent4" accent5="accent5" accent6="accent6" hlink="hlink" folHlink="folHlink"/>
   <p:sldLayoutIdLst>
-    <p:sldLayoutId xmlns:r="http://schemas.openxmlformats.org/officeDocument/2006/relationships" id="2147483649" r:id="Ra4a07e177e304fbd"/>
+    <p:sldLayoutId xmlns:r="http://schemas.openxmlformats.org/officeDocument/2006/relationships" id="2147483649" r:id="Ra3a62c739cae406e"/>
   </p:sldLayoutIdLst>
   <p:hf sldNum="0" hdr="0" ftr="0" dt="0"/>
   <p:txStyles>
@@ -3481,7 +3411,7 @@
           <p:nvPr/>
         </p:nvPicPr>
         <p:blipFill rotWithShape="1">
-          <a:blip xmlns:r="http://schemas.openxmlformats.org/officeDocument/2006/relationships" xmlns:a="http://schemas.openxmlformats.org/drawingml/2006/main" r:embed="Re07cd42d0f8e4d27">
+          <a:blip xmlns:r="http://schemas.openxmlformats.org/officeDocument/2006/relationships" xmlns:a="http://schemas.openxmlformats.org/drawingml/2006/main" r:embed="Rbea135eceee54a61">
             <a:alphaModFix/>
           </a:blip>
           <a:srcRect xmlns:a="http://schemas.openxmlformats.org/drawingml/2006/main" l="0" t="0" r="0" b="0"/>
@@ -4182,7 +4112,7 @@
       </p:sp>
       <p:cxnSp>
         <p:nvCxnSpPr>
-          <p:cNvPr id="236" name="Google Shape;226;p12"/>
+          <p:cNvPr id="245" name="Google Shape;226;p12"/>
           <p:cNvCxnSpPr/>
           <p:nvPr/>
         </p:nvCxnSpPr>
@@ -4828,7 +4758,7 @@
       </p:sp>
       <p:cxnSp>
         <p:nvCxnSpPr>
-          <p:cNvPr id="257" name="Google Shape;241;p13"/>
+          <p:cNvPr id="266" name="Google Shape;241;p13"/>
           <p:cNvCxnSpPr/>
           <p:nvPr/>
         </p:nvCxnSpPr>
@@ -5771,7 +5701,7 @@
       </p:sp>
       <p:cxnSp>
         <p:nvCxnSpPr>
-          <p:cNvPr id="272" name="Google Shape;262;p14"/>
+          <p:cNvPr id="281" name="Google Shape;262;p14"/>
           <p:cNvCxnSpPr/>
           <p:nvPr/>
         </p:nvCxnSpPr>
@@ -6417,7 +6347,7 @@
       </p:sp>
       <p:cxnSp>
         <p:nvCxnSpPr>
-          <p:cNvPr id="289" name="Google Shape;277;p15"/>
+          <p:cNvPr id="298" name="Google Shape;277;p15"/>
           <p:cNvCxnSpPr/>
           <p:nvPr/>
         </p:nvCxnSpPr>
@@ -7135,7 +7065,7 @@
       </p:sp>
       <p:cxnSp>
         <p:nvCxnSpPr>
-          <p:cNvPr id="313" name="Google Shape;294;p16"/>
+          <p:cNvPr id="322" name="Google Shape;294;p16"/>
           <p:cNvCxnSpPr/>
           <p:nvPr/>
         </p:nvCxnSpPr>
@@ -8257,7 +8187,7 @@
       </p:sp>
       <p:cxnSp>
         <p:nvCxnSpPr>
-          <p:cNvPr id="329" name="Google Shape;318;p17"/>
+          <p:cNvPr id="338" name="Google Shape;318;p17"/>
           <p:cNvCxnSpPr/>
           <p:nvPr/>
         </p:nvCxnSpPr>
@@ -9057,7 +8987,7 @@
       </p:sp>
       <p:cxnSp>
         <p:nvCxnSpPr>
-          <p:cNvPr id="346" name="Google Shape;334;p18"/>
+          <p:cNvPr id="355" name="Google Shape;334;p18"/>
           <p:cNvCxnSpPr/>
           <p:nvPr/>
         </p:nvCxnSpPr>
@@ -9797,7 +9727,7 @@
       </p:sp>
       <p:cxnSp>
         <p:nvCxnSpPr>
-          <p:cNvPr id="363" name="Google Shape;351;p19"/>
+          <p:cNvPr id="372" name="Google Shape;351;p19"/>
           <p:cNvCxnSpPr/>
           <p:nvPr/>
         </p:nvCxnSpPr>
@@ -10504,7 +10434,7 @@
       </p:sp>
       <p:cxnSp>
         <p:nvCxnSpPr>
-          <p:cNvPr id="46" name="Google Shape;36;p4"/>
+          <p:cNvPr id="55" name="Google Shape;36;p4"/>
           <p:cNvCxnSpPr/>
           <p:nvPr/>
         </p:nvCxnSpPr>
@@ -11150,7 +11080,7 @@
       </p:sp>
       <p:cxnSp>
         <p:nvCxnSpPr>
-          <p:cNvPr id="66" name="Google Shape;51;p5"/>
+          <p:cNvPr id="75" name="Google Shape;51;p5"/>
           <p:cNvCxnSpPr/>
           <p:nvPr/>
         </p:nvCxnSpPr>
@@ -12216,7 +12146,7 @@
       </p:sp>
       <p:cxnSp>
         <p:nvCxnSpPr>
-          <p:cNvPr id="101" name="Google Shape;71;p6"/>
+          <p:cNvPr id="128" name="Google Shape;71;p6"/>
           <p:cNvCxnSpPr/>
           <p:nvPr/>
         </p:nvCxnSpPr>
@@ -12359,7 +12289,7 @@
       </p:sp>
       <p:cxnSp>
         <p:nvCxnSpPr>
-          <p:cNvPr id="104" name="Google Shape;74;p6"/>
+          <p:cNvPr id="131" name="Google Shape;74;p6"/>
           <p:cNvCxnSpPr/>
           <p:nvPr/>
         </p:nvCxnSpPr>
@@ -12502,7 +12432,7 @@
       </p:sp>
       <p:cxnSp>
         <p:nvCxnSpPr>
-          <p:cNvPr id="107" name="Google Shape;77;p6"/>
+          <p:cNvPr id="134" name="Google Shape;77;p6"/>
           <p:cNvCxnSpPr/>
           <p:nvPr/>
         </p:nvCxnSpPr>
@@ -12645,7 +12575,7 @@
       </p:sp>
       <p:cxnSp>
         <p:nvCxnSpPr>
-          <p:cNvPr id="110" name="Google Shape;80;p6"/>
+          <p:cNvPr id="137" name="Google Shape;80;p6"/>
           <p:cNvCxnSpPr/>
           <p:nvPr/>
         </p:nvCxnSpPr>
@@ -12788,7 +12718,7 @@
       </p:sp>
       <p:cxnSp>
         <p:nvCxnSpPr>
-          <p:cNvPr id="113" name="Google Shape;83;p6"/>
+          <p:cNvPr id="140" name="Google Shape;83;p6"/>
           <p:cNvCxnSpPr/>
           <p:nvPr/>
         </p:nvCxnSpPr>
@@ -12931,7 +12861,7 @@
       </p:sp>
       <p:cxnSp>
         <p:nvCxnSpPr>
-          <p:cNvPr id="116" name="Google Shape;86;p6"/>
+          <p:cNvPr id="143" name="Google Shape;86;p6"/>
           <p:cNvCxnSpPr/>
           <p:nvPr/>
         </p:nvCxnSpPr>
@@ -13074,7 +13004,7 @@
       </p:sp>
       <p:cxnSp>
         <p:nvCxnSpPr>
-          <p:cNvPr id="119" name="Google Shape;89;p6"/>
+          <p:cNvPr id="146" name="Google Shape;89;p6"/>
           <p:cNvCxnSpPr/>
           <p:nvPr/>
         </p:nvCxnSpPr>
@@ -13777,7 +13707,7 @@
       </p:sp>
       <p:cxnSp>
         <p:nvCxnSpPr>
-          <p:cNvPr id="124" name="Google Shape;106;p7"/>
+          <p:cNvPr id="133" name="Google Shape;106;p7"/>
           <p:cNvCxnSpPr/>
           <p:nvPr/>
         </p:nvCxnSpPr>
@@ -14838,7 +14768,7 @@
       </p:sp>
       <p:cxnSp>
         <p:nvCxnSpPr>
-          <p:cNvPr id="154" name="Google Shape;129;p8"/>
+          <p:cNvPr id="163" name="Google Shape;129;p8"/>
           <p:cNvCxnSpPr/>
           <p:nvPr/>
         </p:nvCxnSpPr>
@@ -16318,7 +16248,7 @@
       </p:sp>
       <p:cxnSp>
         <p:nvCxnSpPr>
-          <p:cNvPr id="180" name="Google Shape;159;p9"/>
+          <p:cNvPr id="189" name="Google Shape;159;p9"/>
           <p:cNvCxnSpPr/>
           <p:nvPr/>
         </p:nvCxnSpPr>
@@ -17558,7 +17488,7 @@
       </p:sp>
       <p:cxnSp>
         <p:nvCxnSpPr>
-          <p:cNvPr id="197" name="Google Shape;185;p10"/>
+          <p:cNvPr id="206" name="Google Shape;185;p10"/>
           <p:cNvCxnSpPr/>
           <p:nvPr/>
         </p:nvCxnSpPr>
@@ -18298,7 +18228,7 @@
       </p:sp>
       <p:cxnSp>
         <p:nvCxnSpPr>
-          <p:cNvPr id="221" name="Google Shape;202;p11"/>
+          <p:cNvPr id="230" name="Google Shape;202;p11"/>
           <p:cNvCxnSpPr/>
           <p:nvPr/>
         </p:nvCxnSpPr>

</xml_diff>

<commit_message>
Align weekly support resource mappings
</commit_message>
<xml_diff>
--- a/STARLAB_Slide_Decks_All/01_Authentic_Research_Course_Launch_2.0.pptx
+++ b/STARLAB_Slide_Decks_All/01_Authentic_Research_Course_Launch_2.0.pptx
@@ -2,37 +2,37 @@
 <file path=ppt/presentation.xml><?xml version="1.0" encoding="utf-8"?>
 <p:presentation xmlns:p="http://schemas.openxmlformats.org/presentationml/2006/main" embedTrueTypeFonts="1" saveSubsetFonts="0">
   <p:sldMasterIdLst>
-    <p:sldMasterId xmlns:r="http://schemas.openxmlformats.org/officeDocument/2006/relationships" id="2147483648" r:id="R13d87c35e68f4a63"/>
+    <p:sldMasterId xmlns:r="http://schemas.openxmlformats.org/officeDocument/2006/relationships" id="2147483648" r:id="R2de1c8ffe6ad4088"/>
   </p:sldMasterIdLst>
   <p:notesMasterIdLst>
-    <p:notesMasterId xmlns:r="http://schemas.openxmlformats.org/officeDocument/2006/relationships" r:id="R096b58a7ebfa42e3"/>
+    <p:notesMasterId xmlns:r="http://schemas.openxmlformats.org/officeDocument/2006/relationships" r:id="Rc6d426d6afc844c0"/>
   </p:notesMasterIdLst>
   <p:sldIdLst>
-    <p:sldId xmlns:r="http://schemas.openxmlformats.org/officeDocument/2006/relationships" id="256" r:id="R4c933da7dfba4522"/>
-    <p:sldId xmlns:r="http://schemas.openxmlformats.org/officeDocument/2006/relationships" id="257" r:id="Re56453b1c028458e"/>
-    <p:sldId xmlns:r="http://schemas.openxmlformats.org/officeDocument/2006/relationships" id="258" r:id="R00dc77bcc42a42b4"/>
-    <p:sldId xmlns:r="http://schemas.openxmlformats.org/officeDocument/2006/relationships" id="259" r:id="R6b408aa30332433b"/>
-    <p:sldId xmlns:r="http://schemas.openxmlformats.org/officeDocument/2006/relationships" id="260" r:id="Re70936bdc8574cd4"/>
-    <p:sldId xmlns:r="http://schemas.openxmlformats.org/officeDocument/2006/relationships" id="261" r:id="R4947638a75114e02"/>
-    <p:sldId xmlns:r="http://schemas.openxmlformats.org/officeDocument/2006/relationships" id="262" r:id="R470c5b93026e496e"/>
-    <p:sldId xmlns:r="http://schemas.openxmlformats.org/officeDocument/2006/relationships" id="263" r:id="Rca2c4d53c1a548d4"/>
-    <p:sldId xmlns:r="http://schemas.openxmlformats.org/officeDocument/2006/relationships" id="264" r:id="R80f3b773917147f7"/>
-    <p:sldId xmlns:r="http://schemas.openxmlformats.org/officeDocument/2006/relationships" id="265" r:id="R72a9fbdef93443a6"/>
-    <p:sldId xmlns:r="http://schemas.openxmlformats.org/officeDocument/2006/relationships" id="266" r:id="Rca7e2d0d8323441b"/>
-    <p:sldId xmlns:r="http://schemas.openxmlformats.org/officeDocument/2006/relationships" id="267" r:id="R9f9bf39146dc4dfc"/>
-    <p:sldId xmlns:r="http://schemas.openxmlformats.org/officeDocument/2006/relationships" id="268" r:id="R6247760b0b7c457e"/>
-    <p:sldId xmlns:r="http://schemas.openxmlformats.org/officeDocument/2006/relationships" id="269" r:id="R93684baa530d472a"/>
-    <p:sldId xmlns:r="http://schemas.openxmlformats.org/officeDocument/2006/relationships" id="270" r:id="Rf0fa9cbbdce34b61"/>
-    <p:sldId xmlns:r="http://schemas.openxmlformats.org/officeDocument/2006/relationships" id="271" r:id="R014843ccf8024db3"/>
-    <p:sldId xmlns:r="http://schemas.openxmlformats.org/officeDocument/2006/relationships" id="272" r:id="R74bc1c8bcaef4add"/>
+    <p:sldId xmlns:r="http://schemas.openxmlformats.org/officeDocument/2006/relationships" id="256" r:id="R2e37415b87b9488e"/>
+    <p:sldId xmlns:r="http://schemas.openxmlformats.org/officeDocument/2006/relationships" id="257" r:id="R985a30354f6a450e"/>
+    <p:sldId xmlns:r="http://schemas.openxmlformats.org/officeDocument/2006/relationships" id="258" r:id="R0923773c58b64116"/>
+    <p:sldId xmlns:r="http://schemas.openxmlformats.org/officeDocument/2006/relationships" id="259" r:id="Ra8a7a9e621de4dd1"/>
+    <p:sldId xmlns:r="http://schemas.openxmlformats.org/officeDocument/2006/relationships" id="260" r:id="Rf86ea4b39ea34b21"/>
+    <p:sldId xmlns:r="http://schemas.openxmlformats.org/officeDocument/2006/relationships" id="261" r:id="R23655dfaf21c4c26"/>
+    <p:sldId xmlns:r="http://schemas.openxmlformats.org/officeDocument/2006/relationships" id="262" r:id="R8e1a99517aea43b5"/>
+    <p:sldId xmlns:r="http://schemas.openxmlformats.org/officeDocument/2006/relationships" id="263" r:id="Reb248730bc6f4fba"/>
+    <p:sldId xmlns:r="http://schemas.openxmlformats.org/officeDocument/2006/relationships" id="264" r:id="R140d7586b3b64533"/>
+    <p:sldId xmlns:r="http://schemas.openxmlformats.org/officeDocument/2006/relationships" id="265" r:id="Rbbb6ac8cc2c84398"/>
+    <p:sldId xmlns:r="http://schemas.openxmlformats.org/officeDocument/2006/relationships" id="266" r:id="R72d95f12f5e64faf"/>
+    <p:sldId xmlns:r="http://schemas.openxmlformats.org/officeDocument/2006/relationships" id="267" r:id="R176cc92194764758"/>
+    <p:sldId xmlns:r="http://schemas.openxmlformats.org/officeDocument/2006/relationships" id="268" r:id="R09e24b629216411b"/>
+    <p:sldId xmlns:r="http://schemas.openxmlformats.org/officeDocument/2006/relationships" id="269" r:id="R296f7181c70a4d4e"/>
+    <p:sldId xmlns:r="http://schemas.openxmlformats.org/officeDocument/2006/relationships" id="270" r:id="R17bc45beabf74556"/>
+    <p:sldId xmlns:r="http://schemas.openxmlformats.org/officeDocument/2006/relationships" id="271" r:id="Rc0181f636df5485e"/>
+    <p:sldId xmlns:r="http://schemas.openxmlformats.org/officeDocument/2006/relationships" id="272" r:id="R8448a6960baa484b"/>
   </p:sldIdLst>
   <p:sldSz cx="12192000" cy="6858000"/>
   <p:notesSz cx="6858000" cy="9144000"/>
   <p:embeddedFontLst>
     <p:embeddedFont>
       <p:font typeface="Play"/>
-      <p:regular xmlns:r="http://schemas.openxmlformats.org/officeDocument/2006/relationships" r:id="R89be70f94fe9437e"/>
-      <p:bold xmlns:r="http://schemas.openxmlformats.org/officeDocument/2006/relationships" r:id="Rb3826b5d4fd246ba"/>
+      <p:regular xmlns:r="http://schemas.openxmlformats.org/officeDocument/2006/relationships" r:id="Rac800ac6fb8242e8"/>
+      <p:bold xmlns:r="http://schemas.openxmlformats.org/officeDocument/2006/relationships" r:id="R72963cd3a636411e"/>
     </p:embeddedFont>
   </p:embeddedFontLst>
   <p:defaultTextStyle>
@@ -732,6 +732,76 @@
               <a:buNone/>
             </a:pPr>
             <a:r>
+              <a:t>OPTIONAL / TEACHER REFERENCE FOR WEEK 1</a:t>
+            </a:r>
+          </a:p>
+          <a:p xmlns:a="http://schemas.openxmlformats.org/drawingml/2006/main">
+            <a:pPr marL="0" indent="0" algn="l">
+              <a:spcBef>
+                <a:spcPts val="0"/>
+              </a:spcBef>
+              <a:spcAft>
+                <a:spcPts val="0"/>
+              </a:spcAft>
+              <a:buNone/>
+            </a:pPr>
+            <a:r>
+              <a:t>- Unit 1 Appendix I: Optional Project Card Sorting Activity</a:t>
+            </a:r>
+          </a:p>
+          <a:p xmlns:a="http://schemas.openxmlformats.org/drawingml/2006/main">
+            <a:pPr marL="0" indent="0" algn="l">
+              <a:spcBef>
+                <a:spcPts val="0"/>
+              </a:spcBef>
+              <a:spcAft>
+                <a:spcPts val="0"/>
+              </a:spcAft>
+              <a:buNone/>
+            </a:pPr>
+            <a:r>
+              <a:t>- Unit 1 Appendix J: Optional Initial Parent or Guardian Communication</a:t>
+            </a:r>
+          </a:p>
+          <a:p xmlns:a="http://schemas.openxmlformats.org/drawingml/2006/main">
+            <a:pPr marL="0" indent="0" algn="l">
+              <a:spcBef>
+                <a:spcPts val="0"/>
+              </a:spcBef>
+              <a:spcAft>
+                <a:spcPts val="0"/>
+              </a:spcAft>
+              <a:buNone/>
+            </a:pPr>
+            <a:r>
+              <a:t>- Unit 1 Appendix L: Differentiation and Implementation Notes</a:t>
+            </a:r>
+          </a:p>
+          <a:p xmlns:a="http://schemas.openxmlformats.org/drawingml/2006/main">
+            <a:pPr marL="0" indent="0" algn="l">
+              <a:spcBef>
+                <a:spcPts val="0"/>
+              </a:spcBef>
+              <a:spcAft>
+                <a:spcPts val="0"/>
+              </a:spcAft>
+              <a:buNone/>
+            </a:pPr>
+            <a:r>
+              <a:t/>
+            </a:r>
+          </a:p>
+          <a:p xmlns:a="http://schemas.openxmlformats.org/drawingml/2006/main">
+            <a:pPr marL="0" indent="0" algn="l">
+              <a:spcBef>
+                <a:spcPts val="0"/>
+              </a:spcBef>
+              <a:spcAft>
+                <a:spcPts val="0"/>
+              </a:spcAft>
+              <a:buNone/>
+            </a:pPr>
+            <a:r>
               <a:t>RESOURCE ALIGNMENT</a:t>
             </a:r>
           </a:p>
@@ -2288,7 +2358,7 @@
   </p:cSld>
   <p:clrMap bg1="lt1" tx1="dk1" bg2="dk2" tx2="lt2" accent1="accent1" accent2="accent2" accent3="accent3" accent4="accent4" accent5="accent5" accent6="accent6" hlink="hlink" folHlink="folHlink"/>
   <p:sldLayoutIdLst>
-    <p:sldLayoutId xmlns:r="http://schemas.openxmlformats.org/officeDocument/2006/relationships" id="2147483649" r:id="Ra3a62c739cae406e"/>
+    <p:sldLayoutId xmlns:r="http://schemas.openxmlformats.org/officeDocument/2006/relationships" id="2147483649" r:id="R31431739b53f4ba7"/>
   </p:sldLayoutIdLst>
   <p:hf sldNum="0" hdr="0" ftr="0" dt="0"/>
   <p:txStyles>
@@ -3411,7 +3481,7 @@
           <p:nvPr/>
         </p:nvPicPr>
         <p:blipFill rotWithShape="1">
-          <a:blip xmlns:r="http://schemas.openxmlformats.org/officeDocument/2006/relationships" xmlns:a="http://schemas.openxmlformats.org/drawingml/2006/main" r:embed="Rbea135eceee54a61">
+          <a:blip xmlns:r="http://schemas.openxmlformats.org/officeDocument/2006/relationships" xmlns:a="http://schemas.openxmlformats.org/drawingml/2006/main" r:embed="R8005d5f380e54aa6">
             <a:alphaModFix/>
           </a:blip>
           <a:srcRect xmlns:a="http://schemas.openxmlformats.org/drawingml/2006/main" l="0" t="0" r="0" b="0"/>
@@ -4112,7 +4182,7 @@
       </p:sp>
       <p:cxnSp>
         <p:nvCxnSpPr>
-          <p:cNvPr id="245" name="Google Shape;226;p12"/>
+          <p:cNvPr id="254" name="Google Shape;226;p12"/>
           <p:cNvCxnSpPr/>
           <p:nvPr/>
         </p:nvCxnSpPr>
@@ -4758,7 +4828,7 @@
       </p:sp>
       <p:cxnSp>
         <p:nvCxnSpPr>
-          <p:cNvPr id="266" name="Google Shape;241;p13"/>
+          <p:cNvPr id="275" name="Google Shape;241;p13"/>
           <p:cNvCxnSpPr/>
           <p:nvPr/>
         </p:nvCxnSpPr>
@@ -5701,7 +5771,7 @@
       </p:sp>
       <p:cxnSp>
         <p:nvCxnSpPr>
-          <p:cNvPr id="281" name="Google Shape;262;p14"/>
+          <p:cNvPr id="290" name="Google Shape;262;p14"/>
           <p:cNvCxnSpPr/>
           <p:nvPr/>
         </p:nvCxnSpPr>
@@ -6347,7 +6417,7 @@
       </p:sp>
       <p:cxnSp>
         <p:nvCxnSpPr>
-          <p:cNvPr id="298" name="Google Shape;277;p15"/>
+          <p:cNvPr id="307" name="Google Shape;277;p15"/>
           <p:cNvCxnSpPr/>
           <p:nvPr/>
         </p:nvCxnSpPr>
@@ -7065,7 +7135,7 @@
       </p:sp>
       <p:cxnSp>
         <p:nvCxnSpPr>
-          <p:cNvPr id="322" name="Google Shape;294;p16"/>
+          <p:cNvPr id="331" name="Google Shape;294;p16"/>
           <p:cNvCxnSpPr/>
           <p:nvPr/>
         </p:nvCxnSpPr>
@@ -8187,7 +8257,7 @@
       </p:sp>
       <p:cxnSp>
         <p:nvCxnSpPr>
-          <p:cNvPr id="338" name="Google Shape;318;p17"/>
+          <p:cNvPr id="347" name="Google Shape;318;p17"/>
           <p:cNvCxnSpPr/>
           <p:nvPr/>
         </p:nvCxnSpPr>
@@ -8987,7 +9057,7 @@
       </p:sp>
       <p:cxnSp>
         <p:nvCxnSpPr>
-          <p:cNvPr id="355" name="Google Shape;334;p18"/>
+          <p:cNvPr id="364" name="Google Shape;334;p18"/>
           <p:cNvCxnSpPr/>
           <p:nvPr/>
         </p:nvCxnSpPr>
@@ -9727,7 +9797,7 @@
       </p:sp>
       <p:cxnSp>
         <p:nvCxnSpPr>
-          <p:cNvPr id="372" name="Google Shape;351;p19"/>
+          <p:cNvPr id="381" name="Google Shape;351;p19"/>
           <p:cNvCxnSpPr/>
           <p:nvPr/>
         </p:nvCxnSpPr>
@@ -10434,7 +10504,7 @@
       </p:sp>
       <p:cxnSp>
         <p:nvCxnSpPr>
-          <p:cNvPr id="55" name="Google Shape;36;p4"/>
+          <p:cNvPr id="64" name="Google Shape;36;p4"/>
           <p:cNvCxnSpPr/>
           <p:nvPr/>
         </p:nvCxnSpPr>
@@ -11080,7 +11150,7 @@
       </p:sp>
       <p:cxnSp>
         <p:nvCxnSpPr>
-          <p:cNvPr id="75" name="Google Shape;51;p5"/>
+          <p:cNvPr id="84" name="Google Shape;51;p5"/>
           <p:cNvCxnSpPr/>
           <p:nvPr/>
         </p:nvCxnSpPr>
@@ -12146,7 +12216,7 @@
       </p:sp>
       <p:cxnSp>
         <p:nvCxnSpPr>
-          <p:cNvPr id="128" name="Google Shape;71;p6"/>
+          <p:cNvPr id="155" name="Google Shape;71;p6"/>
           <p:cNvCxnSpPr/>
           <p:nvPr/>
         </p:nvCxnSpPr>
@@ -12289,7 +12359,7 @@
       </p:sp>
       <p:cxnSp>
         <p:nvCxnSpPr>
-          <p:cNvPr id="131" name="Google Shape;74;p6"/>
+          <p:cNvPr id="158" name="Google Shape;74;p6"/>
           <p:cNvCxnSpPr/>
           <p:nvPr/>
         </p:nvCxnSpPr>
@@ -12432,7 +12502,7 @@
       </p:sp>
       <p:cxnSp>
         <p:nvCxnSpPr>
-          <p:cNvPr id="134" name="Google Shape;77;p6"/>
+          <p:cNvPr id="161" name="Google Shape;77;p6"/>
           <p:cNvCxnSpPr/>
           <p:nvPr/>
         </p:nvCxnSpPr>
@@ -12575,7 +12645,7 @@
       </p:sp>
       <p:cxnSp>
         <p:nvCxnSpPr>
-          <p:cNvPr id="137" name="Google Shape;80;p6"/>
+          <p:cNvPr id="164" name="Google Shape;80;p6"/>
           <p:cNvCxnSpPr/>
           <p:nvPr/>
         </p:nvCxnSpPr>
@@ -12718,7 +12788,7 @@
       </p:sp>
       <p:cxnSp>
         <p:nvCxnSpPr>
-          <p:cNvPr id="140" name="Google Shape;83;p6"/>
+          <p:cNvPr id="167" name="Google Shape;83;p6"/>
           <p:cNvCxnSpPr/>
           <p:nvPr/>
         </p:nvCxnSpPr>
@@ -12861,7 +12931,7 @@
       </p:sp>
       <p:cxnSp>
         <p:nvCxnSpPr>
-          <p:cNvPr id="143" name="Google Shape;86;p6"/>
+          <p:cNvPr id="170" name="Google Shape;86;p6"/>
           <p:cNvCxnSpPr/>
           <p:nvPr/>
         </p:nvCxnSpPr>
@@ -13004,7 +13074,7 @@
       </p:sp>
       <p:cxnSp>
         <p:nvCxnSpPr>
-          <p:cNvPr id="146" name="Google Shape;89;p6"/>
+          <p:cNvPr id="173" name="Google Shape;89;p6"/>
           <p:cNvCxnSpPr/>
           <p:nvPr/>
         </p:nvCxnSpPr>
@@ -13707,7 +13777,7 @@
       </p:sp>
       <p:cxnSp>
         <p:nvCxnSpPr>
-          <p:cNvPr id="133" name="Google Shape;106;p7"/>
+          <p:cNvPr id="142" name="Google Shape;106;p7"/>
           <p:cNvCxnSpPr/>
           <p:nvPr/>
         </p:nvCxnSpPr>
@@ -14768,7 +14838,7 @@
       </p:sp>
       <p:cxnSp>
         <p:nvCxnSpPr>
-          <p:cNvPr id="163" name="Google Shape;129;p8"/>
+          <p:cNvPr id="172" name="Google Shape;129;p8"/>
           <p:cNvCxnSpPr/>
           <p:nvPr/>
         </p:nvCxnSpPr>
@@ -16248,7 +16318,7 @@
       </p:sp>
       <p:cxnSp>
         <p:nvCxnSpPr>
-          <p:cNvPr id="189" name="Google Shape;159;p9"/>
+          <p:cNvPr id="198" name="Google Shape;159;p9"/>
           <p:cNvCxnSpPr/>
           <p:nvPr/>
         </p:nvCxnSpPr>
@@ -17488,7 +17558,7 @@
       </p:sp>
       <p:cxnSp>
         <p:nvCxnSpPr>
-          <p:cNvPr id="206" name="Google Shape;185;p10"/>
+          <p:cNvPr id="215" name="Google Shape;185;p10"/>
           <p:cNvCxnSpPr/>
           <p:nvPr/>
         </p:nvCxnSpPr>
@@ -18228,7 +18298,7 @@
       </p:sp>
       <p:cxnSp>
         <p:nvCxnSpPr>
-          <p:cNvPr id="230" name="Google Shape;202;p11"/>
+          <p:cNvPr id="239" name="Google Shape;202;p11"/>
           <p:cNvCxnSpPr/>
           <p:nvPr/>
         </p:nvCxnSpPr>

</xml_diff>